<commit_message>
Adiciona slide 'Fatos e premissas' ao deck CPC 15 x 19
Slide 2 reconstruído no padrão SF: colunas 'Fatos da Transação'
(incorporação a valor contábil com 13,8%; cash out de 26,2% para
60/40; EVs 5.133/822; Acordo 20.10.2025 e BACEN; qualificação
contábil em aberto) e 'Premissas dos exemplos' (PL 31.07.26 = 254;
VJs acordados; segregação DTT 65,4/34,6; cash out 1.200 sem
correções/earn-out; custo alocado 26,2%; 34% e 22,5%), mais faixa
de Ressalvas (presumido/lucro real, ITCMD e caráter ilustrativo).
Validado contra o original e renderizado sem defeitos.

Co-Authored-By: Claude Fable 5 <noreply@anthropic.com>
Claude-Session: https://claude.ai/code/session_014nxthFHMZF8aEXBVoEN5GT
</commit_message>
<xml_diff>
--- a/planilhas/Embracon_CPC_15_x_19_atualizado.pptx
+++ b/planilhas/Embracon_CPC_15_x_19_atualizado.pptx
@@ -5595,17 +5595,20 @@
                 <a:ea typeface="Calibri" panose="020F0502020204030204" pitchFamily="34" charset="0"/>
                 <a:cs typeface="Calibri" panose="020F0502020204030204" pitchFamily="34" charset="0"/>
               </a:rPr>
-              <a:t>Premissas do material.</a:t>
+              <a:t>Fatos e premissas.</a:t>
             </a:r>
             <a:r>
               <a:rPr lang="pt-BR" sz="2400" b="1" cap="small" dirty="0">
                 <a:solidFill>
-                  <a:srgbClr val="EA0600"/>
+                  <a:schemeClr val="tx1">
+                    <a:lumMod val="65000"/>
+                    <a:lumOff val="35000"/>
+                  </a:schemeClr>
                 </a:solidFill>
                 <a:latin typeface="Calibri" panose="020F0502020204030204" pitchFamily="34" charset="0"/>
                 <a:cs typeface="Calibri" panose="020F0502020204030204" pitchFamily="34" charset="0"/>
               </a:rPr>
-              <a:t> </a:t>
+              <a:t> Base dos exemplos numéricos</a:t>
             </a:r>
             <a:endParaRPr lang="pt-BR" sz="2400" b="1" cap="small" dirty="0">
               <a:solidFill>
@@ -5672,7 +5675,753 @@
                 <a:latin typeface="Calibri" panose="020F0502020204030204" pitchFamily="34" charset="0"/>
                 <a:cs typeface="Calibri" panose="020F0502020204030204" pitchFamily="34" charset="0"/>
               </a:rPr>
-              <a:t>SSDSWF</a:t>
+              <a:t>Fatos da Transação, premissas adotadas e ressalvas do material</a:t>
+            </a:r>
+          </a:p>
+        </p:txBody>
+      </p:sp>
+      <p:sp>
+        <p:nvSpPr>
+          <p:cNvPr id="201" name="FatosBox"/>
+          <p:cNvSpPr txBox="1">
+            <a:spLocks/>
+          </p:cNvSpPr>
+          <p:nvPr/>
+        </p:nvSpPr>
+        <p:spPr>
+          <a:xfrm>
+            <a:off x="736237" y="1150000"/>
+            <a:ext cx="4800600" cy="3200000"/>
+          </a:xfrm>
+          <a:prstGeom prst="rect">
+            <a:avLst/>
+          </a:prstGeom>
+        </p:spPr>
+        <p:txBody>
+          <a:bodyPr vert="horz" wrap="square" lIns="0" tIns="0" rIns="45720" bIns="0" rtlCol="0"/>
+          <a:lstStyle/>
+          <a:p>
+            <a:pPr marL="0" indent="0">
+              <a:spcAft>
+                <a:spcPts val="600"/>
+              </a:spcAft>
+              <a:buNone/>
+            </a:pPr>
+            <a:r>
+              <a:rPr lang="pt-BR" sz="1300" b="1" cap="small" dirty="0">
+                <a:solidFill>
+                  <a:srgbClr val="EA0600"/>
+                </a:solidFill>
+                <a:latin typeface="Calibri"/>
+                <a:cs typeface="Calibri"/>
+              </a:rPr>
+              <a:t>Fatos da Transação</a:t>
+            </a:r>
+          </a:p>
+          <a:p>
+            <a:pPr marL="171450" indent="-171450">
+              <a:spcAft>
+                <a:spcPts val="500"/>
+              </a:spcAft>
+              <a:buClr>
+                <a:srgbClr val="595959"/>
+              </a:buClr>
+              <a:buFont typeface="Arial"/>
+              <a:buChar char="▪"/>
+            </a:pPr>
+            <a:r>
+              <a:rPr lang="pt-BR" sz="1150" dirty="0">
+                <a:solidFill>
+                  <a:srgbClr val="262626"/>
+                </a:solidFill>
+                <a:latin typeface="Calibri"/>
+                <a:cs typeface="Calibri"/>
+              </a:rPr>
+              <a:t>Incorporação da CNP pela Embracon, com versão da totalidade do patrimônio e atos societários lavrados a valor patrimonial contábil (laudo do art. 224 da Lei das S.A.); as Partes CNP recebem </a:t>
+            </a:r>
+            <a:r>
+              <a:rPr lang="pt-BR" sz="1150" b="1" dirty="0">
+                <a:solidFill>
+                  <a:srgbClr val="262626"/>
+                </a:solidFill>
+                <a:latin typeface="Calibri"/>
+                <a:cs typeface="Calibri"/>
+              </a:rPr>
+              <a:t>13,8%</a:t>
+            </a:r>
+            <a:r>
+              <a:rPr lang="pt-BR" sz="1150" dirty="0">
+                <a:solidFill>
+                  <a:srgbClr val="262626"/>
+                </a:solidFill>
+                <a:latin typeface="Calibri"/>
+                <a:cs typeface="Calibri"/>
+              </a:rPr>
+              <a:t> do capital da Embracon.</a:t>
+            </a:r>
+          </a:p>
+          <a:p>
+            <a:pPr marL="171450" indent="-171450">
+              <a:spcAft>
+                <a:spcPts val="500"/>
+              </a:spcAft>
+              <a:buClr>
+                <a:srgbClr val="595959"/>
+              </a:buClr>
+              <a:buFont typeface="Arial"/>
+              <a:buChar char="▪"/>
+            </a:pPr>
+            <a:r>
+              <a:rPr lang="pt-BR" sz="1150" dirty="0">
+                <a:solidFill>
+                  <a:srgbClr val="262626"/>
+                </a:solidFill>
+                <a:latin typeface="Calibri"/>
+                <a:cs typeface="Calibri"/>
+              </a:rPr>
+              <a:t>Em ato subsequente e interdependente, aquisição de </a:t>
+            </a:r>
+            <a:r>
+              <a:rPr lang="pt-BR" sz="1150" b="1" dirty="0">
+                <a:solidFill>
+                  <a:srgbClr val="262626"/>
+                </a:solidFill>
+                <a:latin typeface="Calibri"/>
+                <a:cs typeface="Calibri"/>
+              </a:rPr>
+              <a:t>26,2%</a:t>
+            </a:r>
+            <a:r>
+              <a:rPr lang="pt-BR" sz="1150" dirty="0">
+                <a:solidFill>
+                  <a:srgbClr val="262626"/>
+                </a:solidFill>
+                <a:latin typeface="Calibri"/>
+                <a:cs typeface="Calibri"/>
+              </a:rPr>
+              <a:t> detidos por Savian e JVFJ (cash out), resultando em </a:t>
+            </a:r>
+            <a:r>
+              <a:rPr lang="pt-BR" sz="1150" b="1" dirty="0">
+                <a:solidFill>
+                  <a:srgbClr val="262626"/>
+                </a:solidFill>
+                <a:latin typeface="Calibri"/>
+                <a:cs typeface="Calibri"/>
+              </a:rPr>
+              <a:t>60%</a:t>
+            </a:r>
+            <a:r>
+              <a:rPr lang="pt-BR" sz="1150" dirty="0">
+                <a:solidFill>
+                  <a:srgbClr val="262626"/>
+                </a:solidFill>
+                <a:latin typeface="Calibri"/>
+                <a:cs typeface="Calibri"/>
+              </a:rPr>
+              <a:t> famílias (30%/30%) e </a:t>
+            </a:r>
+            <a:r>
+              <a:rPr lang="pt-BR" sz="1150" b="1" dirty="0">
+                <a:solidFill>
+                  <a:srgbClr val="262626"/>
+                </a:solidFill>
+                <a:latin typeface="Calibri"/>
+                <a:cs typeface="Calibri"/>
+              </a:rPr>
+              <a:t>40%</a:t>
+            </a:r>
+            <a:r>
+              <a:rPr lang="pt-BR" sz="1150" dirty="0">
+                <a:solidFill>
+                  <a:srgbClr val="262626"/>
+                </a:solidFill>
+                <a:latin typeface="Calibri"/>
+                <a:cs typeface="Calibri"/>
+              </a:rPr>
+              <a:t> Grupo CNP.</a:t>
+            </a:r>
+          </a:p>
+          <a:p>
+            <a:pPr marL="171450" indent="-171450">
+              <a:spcAft>
+                <a:spcPts val="500"/>
+              </a:spcAft>
+              <a:buClr>
+                <a:srgbClr val="595959"/>
+              </a:buClr>
+              <a:buFont typeface="Arial"/>
+              <a:buChar char="▪"/>
+            </a:pPr>
+            <a:r>
+              <a:rPr lang="pt-BR" sz="1150" dirty="0">
+                <a:solidFill>
+                  <a:srgbClr val="262626"/>
+                </a:solidFill>
+                <a:latin typeface="Calibri"/>
+                <a:cs typeface="Calibri"/>
+              </a:rPr>
+              <a:t>Relação de troca definitiva pelos EVs acordados: Embracon </a:t>
+            </a:r>
+            <a:r>
+              <a:rPr lang="pt-BR" sz="1150" b="1" dirty="0">
+                <a:solidFill>
+                  <a:srgbClr val="262626"/>
+                </a:solidFill>
+                <a:latin typeface="Calibri"/>
+                <a:cs typeface="Calibri"/>
+              </a:rPr>
+              <a:t>5.133</a:t>
+            </a:r>
+            <a:r>
+              <a:rPr lang="pt-BR" sz="1150" dirty="0">
+                <a:solidFill>
+                  <a:srgbClr val="262626"/>
+                </a:solidFill>
+                <a:latin typeface="Calibri"/>
+                <a:cs typeface="Calibri"/>
+              </a:rPr>
+              <a:t> e CNP </a:t>
+            </a:r>
+            <a:r>
+              <a:rPr lang="pt-BR" sz="1150" b="1" dirty="0">
+                <a:solidFill>
+                  <a:srgbClr val="262626"/>
+                </a:solidFill>
+                <a:latin typeface="Calibri"/>
+                <a:cs typeface="Calibri"/>
+              </a:rPr>
+              <a:t>822</a:t>
+            </a:r>
+            <a:r>
+              <a:rPr lang="pt-BR" sz="1150" dirty="0">
+                <a:solidFill>
+                  <a:srgbClr val="262626"/>
+                </a:solidFill>
+                <a:latin typeface="Calibri"/>
+                <a:cs typeface="Calibri"/>
+              </a:rPr>
+              <a:t> (total </a:t>
+            </a:r>
+            <a:r>
+              <a:rPr lang="pt-BR" sz="1150" b="1" dirty="0">
+                <a:solidFill>
+                  <a:srgbClr val="262626"/>
+                </a:solidFill>
+                <a:latin typeface="Calibri"/>
+                <a:cs typeface="Calibri"/>
+              </a:rPr>
+              <a:t>5.955</a:t>
+            </a:r>
+            <a:r>
+              <a:rPr lang="pt-BR" sz="1150" dirty="0">
+                <a:solidFill>
+                  <a:srgbClr val="262626"/>
+                </a:solidFill>
+                <a:latin typeface="Calibri"/>
+                <a:cs typeface="Calibri"/>
+              </a:rPr>
+              <a:t>).</a:t>
+            </a:r>
+          </a:p>
+          <a:p>
+            <a:pPr marL="171450" indent="-171450">
+              <a:spcAft>
+                <a:spcPts val="500"/>
+              </a:spcAft>
+              <a:buClr>
+                <a:srgbClr val="595959"/>
+              </a:buClr>
+              <a:buFont typeface="Arial"/>
+              <a:buChar char="▪"/>
+            </a:pPr>
+            <a:r>
+              <a:rPr lang="pt-BR" sz="1150" dirty="0">
+                <a:solidFill>
+                  <a:srgbClr val="262626"/>
+                </a:solidFill>
+                <a:latin typeface="Calibri"/>
+                <a:cs typeface="Calibri"/>
+              </a:rPr>
+              <a:t>Acordo de 20.10.2025; incorporação, alteração de controle e aumento de capital aprovados pelo BACEN (Ofício 31.070/2026).</a:t>
+            </a:r>
+          </a:p>
+          <a:p>
+            <a:pPr marL="171450" indent="-171450">
+              <a:spcAft>
+                <a:spcPts val="500"/>
+              </a:spcAft>
+              <a:buClr>
+                <a:srgbClr val="595959"/>
+              </a:buClr>
+              <a:buFont typeface="Arial"/>
+              <a:buChar char="▪"/>
+            </a:pPr>
+            <a:r>
+              <a:rPr lang="pt-BR" sz="1150" dirty="0">
+                <a:solidFill>
+                  <a:srgbClr val="262626"/>
+                </a:solidFill>
+                <a:latin typeface="Calibri"/>
+                <a:cs typeface="Calibri"/>
+              </a:rPr>
+              <a:t>A qualificação contábil (CPC 15 x CPC 19) será definida no âmbito da auditoria da Embracon; os documentos da Transação referem “combinação de negócios”.</a:t>
+            </a:r>
+          </a:p>
+        </p:txBody>
+      </p:sp>
+      <p:sp>
+        <p:nvSpPr>
+          <p:cNvPr id="202" name="PremissasBox"/>
+          <p:cNvSpPr txBox="1">
+            <a:spLocks/>
+          </p:cNvSpPr>
+          <p:nvPr/>
+        </p:nvSpPr>
+        <p:spPr>
+          <a:xfrm>
+            <a:off x="5841637" y="1150000"/>
+            <a:ext cx="4800600" cy="3200000"/>
+          </a:xfrm>
+          <a:prstGeom prst="rect">
+            <a:avLst/>
+          </a:prstGeom>
+        </p:spPr>
+        <p:txBody>
+          <a:bodyPr vert="horz" wrap="square" lIns="0" tIns="0" rIns="45720" bIns="0" rtlCol="0"/>
+          <a:lstStyle/>
+          <a:p>
+            <a:pPr marL="0" indent="0">
+              <a:spcAft>
+                <a:spcPts val="600"/>
+              </a:spcAft>
+              <a:buNone/>
+            </a:pPr>
+            <a:r>
+              <a:rPr lang="pt-BR" sz="1300" b="1" cap="small" dirty="0">
+                <a:solidFill>
+                  <a:srgbClr val="EA0600"/>
+                </a:solidFill>
+                <a:latin typeface="Calibri"/>
+                <a:cs typeface="Calibri"/>
+              </a:rPr>
+              <a:t>Premissas dos exemplos</a:t>
+            </a:r>
+          </a:p>
+          <a:p>
+            <a:pPr marL="171450" indent="-171450">
+              <a:spcAft>
+                <a:spcPts val="500"/>
+              </a:spcAft>
+              <a:buClr>
+                <a:srgbClr val="595959"/>
+              </a:buClr>
+              <a:buFont typeface="Arial"/>
+              <a:buChar char="▪"/>
+            </a:pPr>
+            <a:r>
+              <a:rPr lang="pt-BR" sz="1150" dirty="0">
+                <a:solidFill>
+                  <a:srgbClr val="262626"/>
+                </a:solidFill>
+                <a:latin typeface="Calibri"/>
+                <a:cs typeface="Calibri"/>
+              </a:rPr>
+              <a:t>Valores em R$ milhões, arredondados. PLs da Embracon, CNP e holdings cf. planilha enviada pela Embracon (PL da Embracon em 31.07.26: </a:t>
+            </a:r>
+            <a:r>
+              <a:rPr lang="pt-BR" sz="1150" b="1" dirty="0">
+                <a:solidFill>
+                  <a:srgbClr val="262626"/>
+                </a:solidFill>
+                <a:latin typeface="Calibri"/>
+                <a:cs typeface="Calibri"/>
+              </a:rPr>
+              <a:t>254</a:t>
+            </a:r>
+            <a:r>
+              <a:rPr lang="pt-BR" sz="1150" dirty="0">
+                <a:solidFill>
+                  <a:srgbClr val="262626"/>
+                </a:solidFill>
+                <a:latin typeface="Calibri"/>
+                <a:cs typeface="Calibri"/>
+              </a:rPr>
+              <a:t>; custo das holdings = valor patrimonial: 127 cada).</a:t>
+            </a:r>
+          </a:p>
+          <a:p>
+            <a:pPr marL="171450" indent="-171450">
+              <a:spcAft>
+                <a:spcPts val="500"/>
+              </a:spcAft>
+              <a:buClr>
+                <a:srgbClr val="595959"/>
+              </a:buClr>
+              <a:buFont typeface="Arial"/>
+              <a:buChar char="▪"/>
+            </a:pPr>
+            <a:r>
+              <a:rPr lang="pt-BR" sz="1150" dirty="0">
+                <a:solidFill>
+                  <a:srgbClr val="262626"/>
+                </a:solidFill>
+                <a:latin typeface="Calibri"/>
+                <a:cs typeface="Calibri"/>
+              </a:rPr>
+              <a:t>VJ da Embracon = </a:t>
+            </a:r>
+            <a:r>
+              <a:rPr lang="pt-BR" sz="1150" b="1" dirty="0">
+                <a:solidFill>
+                  <a:srgbClr val="262626"/>
+                </a:solidFill>
+                <a:latin typeface="Calibri"/>
+                <a:cs typeface="Calibri"/>
+              </a:rPr>
+              <a:t>5.133</a:t>
+            </a:r>
+            <a:r>
+              <a:rPr lang="pt-BR" sz="1150" dirty="0">
+                <a:solidFill>
+                  <a:srgbClr val="262626"/>
+                </a:solidFill>
+                <a:latin typeface="Calibri"/>
+                <a:cs typeface="Calibri"/>
+              </a:rPr>
+              <a:t> e VJ da CNP = </a:t>
+            </a:r>
+            <a:r>
+              <a:rPr lang="pt-BR" sz="1150" b="1" dirty="0">
+                <a:solidFill>
+                  <a:srgbClr val="262626"/>
+                </a:solidFill>
+                <a:latin typeface="Calibri"/>
+                <a:cs typeface="Calibri"/>
+              </a:rPr>
+              <a:t>822</a:t>
+            </a:r>
+            <a:r>
+              <a:rPr lang="pt-BR" sz="1150" dirty="0">
+                <a:solidFill>
+                  <a:srgbClr val="262626"/>
+                </a:solidFill>
+                <a:latin typeface="Calibri"/>
+                <a:cs typeface="Calibri"/>
+              </a:rPr>
+              <a:t> (EVs acordados; VJ da JO = </a:t>
+            </a:r>
+            <a:r>
+              <a:rPr lang="pt-BR" sz="1150" b="1" dirty="0">
+                <a:solidFill>
+                  <a:srgbClr val="262626"/>
+                </a:solidFill>
+                <a:latin typeface="Calibri"/>
+                <a:cs typeface="Calibri"/>
+              </a:rPr>
+              <a:t>5.955</a:t>
+            </a:r>
+            <a:r>
+              <a:rPr lang="pt-BR" sz="1150" dirty="0">
+                <a:solidFill>
+                  <a:srgbClr val="262626"/>
+                </a:solidFill>
+                <a:latin typeface="Calibri"/>
+                <a:cs typeface="Calibri"/>
+              </a:rPr>
+              <a:t>).</a:t>
+            </a:r>
+          </a:p>
+          <a:p>
+            <a:pPr marL="171450" indent="-171450">
+              <a:spcAft>
+                <a:spcPts val="500"/>
+              </a:spcAft>
+              <a:buClr>
+                <a:srgbClr val="595959"/>
+              </a:buClr>
+              <a:buFont typeface="Arial"/>
+              <a:buChar char="▪"/>
+            </a:pPr>
+            <a:r>
+              <a:rPr lang="pt-BR" sz="1150" dirty="0">
+                <a:solidFill>
+                  <a:srgbClr val="262626"/>
+                </a:solidFill>
+                <a:latin typeface="Calibri"/>
+                <a:cs typeface="Calibri"/>
+              </a:rPr>
+              <a:t>Segregação do PL da CNP entre parcela contábil (</a:t>
+            </a:r>
+            <a:r>
+              <a:rPr lang="pt-BR" sz="1150" b="1" dirty="0">
+                <a:solidFill>
+                  <a:srgbClr val="262626"/>
+                </a:solidFill>
+                <a:latin typeface="Calibri"/>
+                <a:cs typeface="Calibri"/>
+              </a:rPr>
+              <a:t>65,4%</a:t>
+            </a:r>
+            <a:r>
+              <a:rPr lang="pt-BR" sz="1150" dirty="0">
+                <a:solidFill>
+                  <a:srgbClr val="262626"/>
+                </a:solidFill>
+                <a:latin typeface="Calibri"/>
+                <a:cs typeface="Calibri"/>
+              </a:rPr>
+              <a:t>) e AVJ (</a:t>
+            </a:r>
+            <a:r>
+              <a:rPr lang="pt-BR" sz="1150" b="1" dirty="0">
+                <a:solidFill>
+                  <a:srgbClr val="262626"/>
+                </a:solidFill>
+                <a:latin typeface="Calibri"/>
+                <a:cs typeface="Calibri"/>
+              </a:rPr>
+              <a:t>34,6%</a:t>
+            </a:r>
+            <a:r>
+              <a:rPr lang="pt-BR" sz="1150" dirty="0">
+                <a:solidFill>
+                  <a:srgbClr val="262626"/>
+                </a:solidFill>
+                <a:latin typeface="Calibri"/>
+                <a:cs typeface="Calibri"/>
+              </a:rPr>
+              <a:t>), conforme proporção do exercício DTT (866 = 566 + 300).</a:t>
+            </a:r>
+          </a:p>
+          <a:p>
+            <a:pPr marL="171450" indent="-171450">
+              <a:spcAft>
+                <a:spcPts val="500"/>
+              </a:spcAft>
+              <a:buClr>
+                <a:srgbClr val="595959"/>
+              </a:buClr>
+              <a:buFont typeface="Arial"/>
+              <a:buChar char="▪"/>
+            </a:pPr>
+            <a:r>
+              <a:rPr lang="pt-BR" sz="1150" dirty="0">
+                <a:solidFill>
+                  <a:srgbClr val="262626"/>
+                </a:solidFill>
+                <a:latin typeface="Calibri"/>
+                <a:cs typeface="Calibri"/>
+              </a:rPr>
+              <a:t>Cash out = </a:t>
+            </a:r>
+            <a:r>
+              <a:rPr lang="pt-BR" sz="1150" b="1" dirty="0">
+                <a:solidFill>
+                  <a:srgbClr val="262626"/>
+                </a:solidFill>
+                <a:latin typeface="Calibri"/>
+                <a:cs typeface="Calibri"/>
+              </a:rPr>
+              <a:t>1.200</a:t>
+            </a:r>
+            <a:r>
+              <a:rPr lang="pt-BR" sz="1150" dirty="0">
+                <a:solidFill>
+                  <a:srgbClr val="262626"/>
+                </a:solidFill>
+                <a:latin typeface="Calibri"/>
+                <a:cs typeface="Calibri"/>
+              </a:rPr>
+              <a:t>, sem correções (IPCA e ajustes de caixa) e sem earn-out (de até 680); custo alocado à parcela vendida = </a:t>
+            </a:r>
+            <a:r>
+              <a:rPr lang="pt-BR" sz="1150" b="1" dirty="0">
+                <a:solidFill>
+                  <a:srgbClr val="262626"/>
+                </a:solidFill>
+                <a:latin typeface="Calibri"/>
+                <a:cs typeface="Calibri"/>
+              </a:rPr>
+              <a:t>26,2%</a:t>
+            </a:r>
+            <a:r>
+              <a:rPr lang="pt-BR" sz="1150" dirty="0">
+                <a:solidFill>
+                  <a:srgbClr val="262626"/>
+                </a:solidFill>
+                <a:latin typeface="Calibri"/>
+                <a:cs typeface="Calibri"/>
+              </a:rPr>
+              <a:t> do custo do investimento.</a:t>
+            </a:r>
+          </a:p>
+          <a:p>
+            <a:pPr marL="171450" indent="-171450">
+              <a:spcAft>
+                <a:spcPts val="500"/>
+              </a:spcAft>
+              <a:buClr>
+                <a:srgbClr val="595959"/>
+              </a:buClr>
+              <a:buFont typeface="Arial"/>
+              <a:buChar char="▪"/>
+            </a:pPr>
+            <a:r>
+              <a:rPr lang="pt-BR" sz="1150" dirty="0">
+                <a:solidFill>
+                  <a:srgbClr val="262626"/>
+                </a:solidFill>
+                <a:latin typeface="Calibri"/>
+                <a:cs typeface="Calibri"/>
+              </a:rPr>
+              <a:t>IRPJ/CSLL de </a:t>
+            </a:r>
+            <a:r>
+              <a:rPr lang="pt-BR" sz="1150" b="1" dirty="0">
+                <a:solidFill>
+                  <a:srgbClr val="262626"/>
+                </a:solidFill>
+                <a:latin typeface="Calibri"/>
+                <a:cs typeface="Calibri"/>
+              </a:rPr>
+              <a:t>34%</a:t>
+            </a:r>
+            <a:r>
+              <a:rPr lang="pt-BR" sz="1150" dirty="0">
+                <a:solidFill>
+                  <a:srgbClr val="262626"/>
+                </a:solidFill>
+                <a:latin typeface="Calibri"/>
+                <a:cs typeface="Calibri"/>
+              </a:rPr>
+              <a:t> sobre o ganho de capital das holdings; venda pelas PFs com alíquota simplificada de </a:t>
+            </a:r>
+            <a:r>
+              <a:rPr lang="pt-BR" sz="1150" b="1" dirty="0">
+                <a:solidFill>
+                  <a:srgbClr val="262626"/>
+                </a:solidFill>
+                <a:latin typeface="Calibri"/>
+                <a:cs typeface="Calibri"/>
+              </a:rPr>
+              <a:t>22,5%</a:t>
+            </a:r>
+            <a:r>
+              <a:rPr lang="pt-BR" sz="1150" dirty="0">
+                <a:solidFill>
+                  <a:srgbClr val="262626"/>
+                </a:solidFill>
+                <a:latin typeface="Calibri"/>
+                <a:cs typeface="Calibri"/>
+              </a:rPr>
+              <a:t>.</a:t>
+            </a:r>
+          </a:p>
+        </p:txBody>
+      </p:sp>
+      <p:sp>
+        <p:nvSpPr>
+          <p:cNvPr id="203" name="RessalvasBox"/>
+          <p:cNvSpPr txBox="1">
+            <a:spLocks/>
+          </p:cNvSpPr>
+          <p:nvPr/>
+        </p:nvSpPr>
+        <p:spPr>
+          <a:xfrm>
+            <a:off x="736237" y="4550000"/>
+            <a:ext cx="9906000" cy="1850000"/>
+          </a:xfrm>
+          <a:prstGeom prst="rect">
+            <a:avLst/>
+          </a:prstGeom>
+        </p:spPr>
+        <p:txBody>
+          <a:bodyPr vert="horz" wrap="square" lIns="0" tIns="0" rIns="45720" bIns="0" rtlCol="0"/>
+          <a:lstStyle/>
+          <a:p>
+            <a:pPr marL="0" indent="0">
+              <a:spcAft>
+                <a:spcPts val="600"/>
+              </a:spcAft>
+              <a:buNone/>
+            </a:pPr>
+            <a:r>
+              <a:rPr lang="pt-BR" sz="1300" b="1" cap="small" dirty="0">
+                <a:solidFill>
+                  <a:srgbClr val="EA0600"/>
+                </a:solidFill>
+                <a:latin typeface="Calibri"/>
+                <a:cs typeface="Calibri"/>
+              </a:rPr>
+              <a:t>Ressalvas</a:t>
+            </a:r>
+          </a:p>
+          <a:p>
+            <a:pPr marL="171450" indent="-171450">
+              <a:spcAft>
+                <a:spcPts val="500"/>
+              </a:spcAft>
+              <a:buClr>
+                <a:srgbClr val="595959"/>
+              </a:buClr>
+              <a:buFont typeface="Arial"/>
+              <a:buChar char="▪"/>
+            </a:pPr>
+            <a:r>
+              <a:rPr lang="pt-BR" sz="1150" dirty="0">
+                <a:solidFill>
+                  <a:srgbClr val="262626"/>
+                </a:solidFill>
+                <a:latin typeface="Calibri"/>
+                <a:cs typeface="Calibri"/>
+              </a:rPr>
+              <a:t>As holdings apuram pelo lucro presumido — premissa relevante para a tributação do cash out. Na venda futura dos 60%, a tributação efetiva poderá ser reduzida caso as holdings estejam no lucro real e disponham de prejuízos correntes suficientes.</a:t>
+            </a:r>
+          </a:p>
+          <a:p>
+            <a:pPr marL="171450" indent="-171450">
+              <a:spcAft>
+                <a:spcPts val="500"/>
+              </a:spcAft>
+              <a:buClr>
+                <a:srgbClr val="595959"/>
+              </a:buClr>
+              <a:buFont typeface="Arial"/>
+              <a:buChar char="▪"/>
+            </a:pPr>
+            <a:r>
+              <a:rPr lang="pt-BR" sz="1150" dirty="0">
+                <a:solidFill>
+                  <a:srgbClr val="262626"/>
+                </a:solidFill>
+                <a:latin typeface="Calibri"/>
+                <a:cs typeface="Calibri"/>
+              </a:rPr>
+              <a:t>Este material não aborda os impactos de ITCMD. Registre-se, contudo, que, conforme discutido na reunião de 31.08, a base de cálculo do ITCMD tende a ser maior no cenário de JO, por elevar o valor patrimonial das holdings ao valor justo tanto da CNP quanto da Embracon.</a:t>
+            </a:r>
+          </a:p>
+          <a:p>
+            <a:pPr marL="171450" indent="-171450">
+              <a:spcAft>
+                <a:spcPts val="500"/>
+              </a:spcAft>
+              <a:buClr>
+                <a:srgbClr val="595959"/>
+              </a:buClr>
+              <a:buFont typeface="Arial"/>
+              <a:buChar char="▪"/>
+            </a:pPr>
+            <a:r>
+              <a:rPr lang="pt-BR" sz="1150" dirty="0">
+                <a:solidFill>
+                  <a:srgbClr val="262626"/>
+                </a:solidFill>
+                <a:latin typeface="Calibri"/>
+                <a:cs typeface="Calibri"/>
+              </a:rPr>
+              <a:t>Exemplos meramente ilustrativos, elaborados a partir de informações não auditadas; não substituem a análise dos documentos finais da Transação e da contabilização efetivamente adotada.</a:t>
             </a:r>
           </a:p>
         </p:txBody>

</xml_diff>